<commit_message>
updated readme and added ppt workflow
</commit_message>
<xml_diff>
--- a/LED DISPLAY.pptx
+++ b/LED DISPLAY.pptx
@@ -13,6 +13,8 @@
     <p:sldId id="262" r:id="rId7"/>
     <p:sldId id="264" r:id="rId8"/>
     <p:sldId id="265" r:id="rId9"/>
+    <p:sldId id="266" r:id="rId10"/>
+    <p:sldId id="267" r:id="rId11"/>
   </p:sldIdLst>
   <p:sldSz cx="12192000" cy="6858000"/>
   <p:notesSz cx="6858000" cy="9144000"/>
@@ -3416,6 +3418,180 @@
 </p:sld>
 </file>
 
+<file path=ppt/slides/slide10.xml><?xml version="1.0" encoding="utf-8"?>
+<p:sld xmlns:a="http://schemas.openxmlformats.org/drawingml/2006/main" xmlns:r="http://schemas.openxmlformats.org/officeDocument/2006/relationships" xmlns:p="http://schemas.openxmlformats.org/presentationml/2006/main">
+  <p:cSld>
+    <p:spTree>
+      <p:nvGrpSpPr>
+        <p:cNvPr id="1" name=""/>
+        <p:cNvGrpSpPr/>
+        <p:nvPr/>
+      </p:nvGrpSpPr>
+      <p:grpSpPr>
+        <a:xfrm>
+          <a:off x="0" y="0"/>
+          <a:ext cx="0" cy="0"/>
+          <a:chOff x="0" y="0"/>
+          <a:chExt cx="0" cy="0"/>
+        </a:xfrm>
+      </p:grpSpPr>
+      <p:pic>
+        <p:nvPicPr>
+          <p:cNvPr id="5" name="Content Placeholder 4">
+            <a:extLst>
+              <a:ext uri="{FF2B5EF4-FFF2-40B4-BE49-F238E27FC236}">
+                <a16:creationId xmlns:a16="http://schemas.microsoft.com/office/drawing/2014/main" id="{EF0FF42B-08EA-D808-9415-FC2524F0EA4D}"/>
+              </a:ext>
+            </a:extLst>
+          </p:cNvPr>
+          <p:cNvPicPr>
+            <a:picLocks noGrp="1" noChangeAspect="1"/>
+          </p:cNvPicPr>
+          <p:nvPr>
+            <p:ph idx="1"/>
+          </p:nvPr>
+        </p:nvPicPr>
+        <p:blipFill>
+          <a:blip r:embed="rId2"/>
+          <a:stretch>
+            <a:fillRect/>
+          </a:stretch>
+        </p:blipFill>
+        <p:spPr>
+          <a:xfrm>
+            <a:off x="838200" y="1779977"/>
+            <a:ext cx="1546994" cy="2004234"/>
+          </a:xfrm>
+          <a:prstGeom prst="rect">
+            <a:avLst/>
+          </a:prstGeom>
+        </p:spPr>
+      </p:pic>
+      <p:pic>
+        <p:nvPicPr>
+          <p:cNvPr id="7" name="Picture 6">
+            <a:extLst>
+              <a:ext uri="{FF2B5EF4-FFF2-40B4-BE49-F238E27FC236}">
+                <a16:creationId xmlns:a16="http://schemas.microsoft.com/office/drawing/2014/main" id="{A2F3B578-8893-2C1F-E0D2-110D92D6E166}"/>
+              </a:ext>
+            </a:extLst>
+          </p:cNvPr>
+          <p:cNvPicPr>
+            <a:picLocks noChangeAspect="1"/>
+          </p:cNvPicPr>
+          <p:nvPr/>
+        </p:nvPicPr>
+        <p:blipFill>
+          <a:blip r:embed="rId3"/>
+          <a:stretch>
+            <a:fillRect/>
+          </a:stretch>
+        </p:blipFill>
+        <p:spPr>
+          <a:xfrm>
+            <a:off x="5133975" y="0"/>
+            <a:ext cx="6983883" cy="6606783"/>
+          </a:xfrm>
+          <a:prstGeom prst="rect">
+            <a:avLst/>
+          </a:prstGeom>
+        </p:spPr>
+      </p:pic>
+      <p:sp>
+        <p:nvSpPr>
+          <p:cNvPr id="9" name="TextBox 8">
+            <a:extLst>
+              <a:ext uri="{FF2B5EF4-FFF2-40B4-BE49-F238E27FC236}">
+                <a16:creationId xmlns:a16="http://schemas.microsoft.com/office/drawing/2014/main" id="{9C21B860-85EF-6E57-B59C-7D89CFCD96C5}"/>
+              </a:ext>
+            </a:extLst>
+          </p:cNvPr>
+          <p:cNvSpPr txBox="1"/>
+          <p:nvPr/>
+        </p:nvSpPr>
+        <p:spPr>
+          <a:xfrm>
+            <a:off x="4233862" y="2494352"/>
+            <a:ext cx="2214563" cy="1200329"/>
+          </a:xfrm>
+          <a:prstGeom prst="rect">
+            <a:avLst/>
+          </a:prstGeom>
+          <a:noFill/>
+        </p:spPr>
+        <p:txBody>
+          <a:bodyPr wrap="square">
+            <a:spAutoFit/>
+          </a:bodyPr>
+          <a:lstStyle/>
+          <a:p>
+            <a:r>
+              <a:rPr lang="en-AU" dirty="0">
+                <a:hlinkClick r:id="rId4"/>
+              </a:rPr>
+              <a:t>https://www.rxelectronics.com.ua/datasheet/64/kwm-20881ava.pdf</a:t>
+            </a:r>
+            <a:r>
+              <a:rPr lang="en-AU" dirty="0"/>
+              <a:t> </a:t>
+            </a:r>
+          </a:p>
+        </p:txBody>
+      </p:sp>
+      <p:sp>
+        <p:nvSpPr>
+          <p:cNvPr id="11" name="TextBox 10">
+            <a:extLst>
+              <a:ext uri="{FF2B5EF4-FFF2-40B4-BE49-F238E27FC236}">
+                <a16:creationId xmlns:a16="http://schemas.microsoft.com/office/drawing/2014/main" id="{BCB5443D-B32D-411C-EB77-37BC4F33C7C4}"/>
+              </a:ext>
+            </a:extLst>
+          </p:cNvPr>
+          <p:cNvSpPr txBox="1"/>
+          <p:nvPr/>
+        </p:nvSpPr>
+        <p:spPr>
+          <a:xfrm>
+            <a:off x="371475" y="4020918"/>
+            <a:ext cx="2400300" cy="1477328"/>
+          </a:xfrm>
+          <a:prstGeom prst="rect">
+            <a:avLst/>
+          </a:prstGeom>
+          <a:noFill/>
+        </p:spPr>
+        <p:txBody>
+          <a:bodyPr wrap="square">
+            <a:spAutoFit/>
+          </a:bodyPr>
+          <a:lstStyle/>
+          <a:p>
+            <a:r>
+              <a:rPr lang="en-AU" dirty="0">
+                <a:hlinkClick r:id="rId5"/>
+              </a:rPr>
+              <a:t>https://mm.digikey.com/Volume0/opasdata/d220001/medias/docus/8903/XL-B1010RGBT-HF.pdf</a:t>
+            </a:r>
+            <a:r>
+              <a:rPr lang="en-AU" dirty="0"/>
+              <a:t> </a:t>
+            </a:r>
+          </a:p>
+        </p:txBody>
+      </p:sp>
+    </p:spTree>
+    <p:extLst>
+      <p:ext uri="{BB962C8B-B14F-4D97-AF65-F5344CB8AC3E}">
+        <p14:creationId xmlns:p14="http://schemas.microsoft.com/office/powerpoint/2010/main" val="3341434759"/>
+      </p:ext>
+    </p:extLst>
+  </p:cSld>
+  <p:clrMapOvr>
+    <a:masterClrMapping/>
+  </p:clrMapOvr>
+</p:sld>
+</file>
+
 <file path=ppt/slides/slide2.xml><?xml version="1.0" encoding="utf-8"?>
 <p:sld xmlns:a="http://schemas.openxmlformats.org/drawingml/2006/main" xmlns:r="http://schemas.openxmlformats.org/officeDocument/2006/relationships" xmlns:p="http://schemas.openxmlformats.org/presentationml/2006/main">
   <p:cSld>
@@ -8619,6 +8795,187 @@
     <p:extLst>
       <p:ext uri="{BB962C8B-B14F-4D97-AF65-F5344CB8AC3E}">
         <p14:creationId xmlns:p14="http://schemas.microsoft.com/office/powerpoint/2010/main" val="348671967"/>
+      </p:ext>
+    </p:extLst>
+  </p:cSld>
+  <p:clrMapOvr>
+    <a:masterClrMapping/>
+  </p:clrMapOvr>
+</p:sld>
+</file>
+
+<file path=ppt/slides/slide9.xml><?xml version="1.0" encoding="utf-8"?>
+<p:sld xmlns:a="http://schemas.openxmlformats.org/drawingml/2006/main" xmlns:r="http://schemas.openxmlformats.org/officeDocument/2006/relationships" xmlns:p="http://schemas.openxmlformats.org/presentationml/2006/main">
+  <p:cSld>
+    <p:spTree>
+      <p:nvGrpSpPr>
+        <p:cNvPr id="1" name=""/>
+        <p:cNvGrpSpPr/>
+        <p:nvPr/>
+      </p:nvGrpSpPr>
+      <p:grpSpPr>
+        <a:xfrm>
+          <a:off x="0" y="0"/>
+          <a:ext cx="0" cy="0"/>
+          <a:chOff x="0" y="0"/>
+          <a:chExt cx="0" cy="0"/>
+        </a:xfrm>
+      </p:grpSpPr>
+      <p:sp>
+        <p:nvSpPr>
+          <p:cNvPr id="2" name="Title 1">
+            <a:extLst>
+              <a:ext uri="{FF2B5EF4-FFF2-40B4-BE49-F238E27FC236}">
+                <a16:creationId xmlns:a16="http://schemas.microsoft.com/office/drawing/2014/main" id="{334448FC-A1ED-20A5-FB84-03B39ED10386}"/>
+              </a:ext>
+            </a:extLst>
+          </p:cNvPr>
+          <p:cNvSpPr>
+            <a:spLocks noGrp="1"/>
+          </p:cNvSpPr>
+          <p:nvPr>
+            <p:ph type="title"/>
+          </p:nvPr>
+        </p:nvSpPr>
+        <p:spPr/>
+        <p:txBody>
+          <a:bodyPr/>
+          <a:lstStyle/>
+          <a:p>
+            <a:endParaRPr lang="en-AU" dirty="0"/>
+          </a:p>
+        </p:txBody>
+      </p:sp>
+      <p:sp>
+        <p:nvSpPr>
+          <p:cNvPr id="3" name="Content Placeholder 2">
+            <a:extLst>
+              <a:ext uri="{FF2B5EF4-FFF2-40B4-BE49-F238E27FC236}">
+                <a16:creationId xmlns:a16="http://schemas.microsoft.com/office/drawing/2014/main" id="{DC66EC1A-8F88-1E16-7E48-4DA0232F558B}"/>
+              </a:ext>
+            </a:extLst>
+          </p:cNvPr>
+          <p:cNvSpPr>
+            <a:spLocks noGrp="1"/>
+          </p:cNvSpPr>
+          <p:nvPr>
+            <p:ph idx="1"/>
+          </p:nvPr>
+        </p:nvSpPr>
+        <p:spPr/>
+        <p:txBody>
+          <a:bodyPr>
+            <a:normAutofit fontScale="92500" lnSpcReduction="20000"/>
+          </a:bodyPr>
+          <a:lstStyle/>
+          <a:p>
+            <a:pPr marL="0" indent="0">
+              <a:buNone/>
+            </a:pPr>
+            <a:r>
+              <a:rPr lang="en-GB" dirty="0"/>
+              <a:t>Each led array is 1.20 which means it would be 120 bucks just for this simple desk display which I could probably buy from </a:t>
+            </a:r>
+            <a:r>
+              <a:rPr lang="en-GB" dirty="0" err="1"/>
+              <a:t>temu</a:t>
+            </a:r>
+            <a:r>
+              <a:rPr lang="en-GB" dirty="0"/>
+              <a:t> for less than 20.</a:t>
+            </a:r>
+          </a:p>
+          <a:p>
+            <a:pPr marL="0" indent="0">
+              <a:buNone/>
+            </a:pPr>
+            <a:endParaRPr lang="en-GB" dirty="0"/>
+          </a:p>
+          <a:p>
+            <a:pPr marL="0" indent="0">
+              <a:buNone/>
+            </a:pPr>
+            <a:r>
+              <a:rPr lang="en-GB" dirty="0"/>
+              <a:t>Maybe I can make my own led array for less than 1.20?</a:t>
+            </a:r>
+          </a:p>
+          <a:p>
+            <a:pPr marL="0" indent="0">
+              <a:buNone/>
+            </a:pPr>
+            <a:endParaRPr lang="en-GB" dirty="0"/>
+          </a:p>
+          <a:p>
+            <a:pPr marL="0" indent="0">
+              <a:buNone/>
+            </a:pPr>
+            <a:r>
+              <a:rPr lang="en-GB" dirty="0"/>
+              <a:t>If I can make a 20x20mm array with 8x8 </a:t>
+            </a:r>
+            <a:r>
+              <a:rPr lang="en-GB" dirty="0" err="1"/>
+              <a:t>leds</a:t>
+            </a:r>
+            <a:r>
+              <a:rPr lang="en-GB" dirty="0"/>
+              <a:t> for less than 0.20 each for materials then that would be worth while.</a:t>
+            </a:r>
+          </a:p>
+          <a:p>
+            <a:pPr marL="0" indent="0">
+              <a:buNone/>
+            </a:pPr>
+            <a:endParaRPr lang="en-GB" dirty="0"/>
+          </a:p>
+          <a:p>
+            <a:pPr marL="0" indent="0">
+              <a:buNone/>
+            </a:pPr>
+            <a:r>
+              <a:rPr lang="en-GB" dirty="0"/>
+              <a:t>Maybe make a 32x32 led screen using these </a:t>
+            </a:r>
+            <a:r>
+              <a:rPr lang="en-GB" dirty="0" err="1"/>
+              <a:t>leds</a:t>
+            </a:r>
+            <a:endParaRPr lang="en-GB" dirty="0"/>
+          </a:p>
+          <a:p>
+            <a:pPr marL="0" indent="0">
+              <a:buNone/>
+            </a:pPr>
+            <a:r>
+              <a:rPr lang="en-GB" dirty="0">
+                <a:hlinkClick r:id="rId2"/>
+              </a:rPr>
+              <a:t>https://www.digikey.com.au/en/products/detail/xinglight/XL-B1010RGBT-HF/25673321</a:t>
+            </a:r>
+            <a:r>
+              <a:rPr lang="en-GB" dirty="0"/>
+              <a:t> </a:t>
+            </a:r>
+          </a:p>
+          <a:p>
+            <a:pPr marL="0" indent="0">
+              <a:buNone/>
+            </a:pPr>
+            <a:endParaRPr lang="en-GB" dirty="0"/>
+          </a:p>
+          <a:p>
+            <a:pPr marL="0" indent="0">
+              <a:buNone/>
+            </a:pPr>
+            <a:endParaRPr lang="en-AU" dirty="0"/>
+          </a:p>
+        </p:txBody>
+      </p:sp>
+    </p:spTree>
+    <p:extLst>
+      <p:ext uri="{BB962C8B-B14F-4D97-AF65-F5344CB8AC3E}">
+        <p14:creationId xmlns:p14="http://schemas.microsoft.com/office/powerpoint/2010/main" val="3814727189"/>
       </p:ext>
     </p:extLst>
   </p:cSld>

</xml_diff>